<commit_message>
Presentation: redesigned cover slide
Co-Authored-By: Claude Opus 5.5 <noreply@anthropic.com>
</commit_message>
<xml_diff>
--- a/presentation/AndroidWorld_GUI_Agent_Presentation.pptx
+++ b/presentation/AndroidWorld_GUI_Agent_Presentation.pptx
@@ -7007,7 +7007,91 @@
         <p:spPr>
           <a:xfrm>
             <a:off x="0" y="0"/>
-            <a:ext cx="12191695" cy="73152"/>
+            <a:ext cx="12191695" cy="6858000"/>
+          </a:xfrm>
+          <a:prstGeom prst="rect">
+            <a:avLst/>
+          </a:prstGeom>
+          <a:solidFill>
+            <a:srgbClr val="EEF3F8"/>
+          </a:solidFill>
+          <a:ln>
+            <a:noFill/>
+          </a:ln>
+          <a:effectLst/>
+        </p:spPr>
+        <p:style>
+          <a:lnRef idx="1">
+            <a:schemeClr val="accent1"/>
+          </a:lnRef>
+          <a:fillRef idx="3">
+            <a:schemeClr val="accent1"/>
+          </a:fillRef>
+          <a:effectRef idx="2">
+            <a:schemeClr val="accent1"/>
+          </a:effectRef>
+          <a:fontRef idx="minor">
+            <a:schemeClr val="lt1"/>
+          </a:fontRef>
+        </p:style>
+        <p:txBody>
+          <a:bodyPr rtlCol="0" anchor="ctr"/>
+          <a:lstStyle/>
+          <a:p/>
+        </p:txBody>
+      </p:sp>
+      <p:sp>
+        <p:nvSpPr>
+          <p:cNvPr id="3" name="Rectangle 2"/>
+          <p:cNvSpPr/>
+          <p:nvPr/>
+        </p:nvSpPr>
+        <p:spPr>
+          <a:xfrm>
+            <a:off x="0" y="0"/>
+            <a:ext cx="7223760" cy="6858000"/>
+          </a:xfrm>
+          <a:prstGeom prst="rect">
+            <a:avLst/>
+          </a:prstGeom>
+          <a:solidFill>
+            <a:srgbClr val="072140"/>
+          </a:solidFill>
+          <a:ln>
+            <a:noFill/>
+          </a:ln>
+          <a:effectLst/>
+        </p:spPr>
+        <p:style>
+          <a:lnRef idx="1">
+            <a:schemeClr val="accent1"/>
+          </a:lnRef>
+          <a:fillRef idx="3">
+            <a:schemeClr val="accent1"/>
+          </a:fillRef>
+          <a:effectRef idx="2">
+            <a:schemeClr val="accent1"/>
+          </a:effectRef>
+          <a:fontRef idx="minor">
+            <a:schemeClr val="lt1"/>
+          </a:fontRef>
+        </p:style>
+        <p:txBody>
+          <a:bodyPr rtlCol="0" anchor="ctr"/>
+          <a:lstStyle/>
+          <a:p/>
+        </p:txBody>
+      </p:sp>
+      <p:sp>
+        <p:nvSpPr>
+          <p:cNvPr id="4" name="Rectangle 3"/>
+          <p:cNvSpPr/>
+          <p:nvPr/>
+        </p:nvSpPr>
+        <p:spPr>
+          <a:xfrm>
+            <a:off x="0" y="0"/>
+            <a:ext cx="7223760" cy="73152"/>
           </a:xfrm>
           <a:prstGeom prst="rect">
             <a:avLst/>
@@ -7042,14 +7126,673 @@
       </p:sp>
       <p:sp>
         <p:nvSpPr>
-          <p:cNvPr id="3" name="TextBox 2"/>
+          <p:cNvPr id="5" name="TextBox 4"/>
           <p:cNvSpPr txBox="1"/>
           <p:nvPr/>
         </p:nvSpPr>
         <p:spPr>
           <a:xfrm>
-            <a:off x="822960" y="914400"/>
-            <a:ext cx="10515600" cy="548640"/>
+            <a:off x="685800" y="640080"/>
+            <a:ext cx="6217920" cy="320040"/>
+          </a:xfrm>
+          <a:prstGeom prst="rect">
+            <a:avLst/>
+          </a:prstGeom>
+          <a:noFill/>
+        </p:spPr>
+        <p:txBody>
+          <a:bodyPr wrap="square" anchor="t" lIns="73152" rIns="73152">
+            <a:spAutoFit/>
+          </a:bodyPr>
+          <a:lstStyle/>
+          <a:p>
+            <a:pPr algn="l">
+              <a:lnSpc>
+                <a:spcPct val="110000"/>
+              </a:lnSpc>
+            </a:pPr>
+            <a:r>
+              <a:rPr sz="1300" b="1" i="0">
+                <a:solidFill>
+                  <a:srgbClr val="64A0C8"/>
+                </a:solidFill>
+                <a:latin typeface="Arial"/>
+              </a:rPr>
+              <a:t>AGENTIC AI IN MODERN BUSINESS  ·  PRESENTATION</a:t>
+            </a:r>
+          </a:p>
+        </p:txBody>
+      </p:sp>
+      <p:sp>
+        <p:nvSpPr>
+          <p:cNvPr id="6" name="TextBox 5"/>
+          <p:cNvSpPr txBox="1"/>
+          <p:nvPr/>
+        </p:nvSpPr>
+        <p:spPr>
+          <a:xfrm>
+            <a:off x="685800" y="932688"/>
+            <a:ext cx="6217920" cy="320040"/>
+          </a:xfrm>
+          <a:prstGeom prst="rect">
+            <a:avLst/>
+          </a:prstGeom>
+          <a:noFill/>
+        </p:spPr>
+        <p:txBody>
+          <a:bodyPr wrap="square" anchor="t" lIns="73152" rIns="73152">
+            <a:spAutoFit/>
+          </a:bodyPr>
+          <a:lstStyle/>
+          <a:p>
+            <a:pPr algn="l">
+              <a:lnSpc>
+                <a:spcPct val="110000"/>
+              </a:lnSpc>
+            </a:pPr>
+            <a:r>
+              <a:rPr sz="1300" b="0" i="0">
+                <a:solidFill>
+                  <a:srgbClr val="B9C4D6"/>
+                </a:solidFill>
+                <a:latin typeface="Arial"/>
+              </a:rPr>
+              <a:t>TUM School of Management</a:t>
+            </a:r>
+          </a:p>
+        </p:txBody>
+      </p:sp>
+      <p:sp>
+        <p:nvSpPr>
+          <p:cNvPr id="7" name="TextBox 6"/>
+          <p:cNvSpPr txBox="1"/>
+          <p:nvPr/>
+        </p:nvSpPr>
+        <p:spPr>
+          <a:xfrm>
+            <a:off x="685800" y="1463040"/>
+            <a:ext cx="6400800" cy="1188720"/>
+          </a:xfrm>
+          <a:prstGeom prst="rect">
+            <a:avLst/>
+          </a:prstGeom>
+          <a:noFill/>
+        </p:spPr>
+        <p:txBody>
+          <a:bodyPr wrap="square" anchor="t" lIns="73152" rIns="73152">
+            <a:spAutoFit/>
+          </a:bodyPr>
+          <a:lstStyle/>
+          <a:p>
+            <a:pPr algn="l">
+              <a:lnSpc>
+                <a:spcPct val="100000"/>
+              </a:lnSpc>
+            </a:pPr>
+            <a:r>
+              <a:rPr sz="3400" b="1" i="0">
+                <a:solidFill>
+                  <a:srgbClr val="FFFFFF"/>
+                </a:solidFill>
+                <a:latin typeface="Arial"/>
+              </a:rPr>
+              <a:t>One GUI agent for seven</a:t>
+            </a:r>
+          </a:p>
+          <a:p>
+            <a:pPr algn="l">
+              <a:lnSpc>
+                <a:spcPct val="100000"/>
+              </a:lnSpc>
+            </a:pPr>
+            <a:r>
+              <a:rPr sz="3400" b="1" i="0">
+                <a:solidFill>
+                  <a:srgbClr val="FFFFFF"/>
+                </a:solidFill>
+                <a:latin typeface="Arial"/>
+              </a:rPr>
+              <a:t>AndroidWorld tasks</a:t>
+            </a:r>
+          </a:p>
+        </p:txBody>
+      </p:sp>
+      <p:sp>
+        <p:nvSpPr>
+          <p:cNvPr id="8" name="TextBox 7"/>
+          <p:cNvSpPr txBox="1"/>
+          <p:nvPr/>
+        </p:nvSpPr>
+        <p:spPr>
+          <a:xfrm>
+            <a:off x="685800" y="2788920"/>
+            <a:ext cx="6035040" cy="777240"/>
+          </a:xfrm>
+          <a:prstGeom prst="rect">
+            <a:avLst/>
+          </a:prstGeom>
+          <a:noFill/>
+        </p:spPr>
+        <p:txBody>
+          <a:bodyPr wrap="square" anchor="t" lIns="73152" rIns="73152">
+            <a:spAutoFit/>
+          </a:bodyPr>
+          <a:lstStyle/>
+          <a:p>
+            <a:pPr algn="l">
+              <a:lnSpc>
+                <a:spcPct val="115000"/>
+              </a:lnSpc>
+            </a:pPr>
+            <a:r>
+              <a:rPr sz="1600" b="0" i="0">
+                <a:solidFill>
+                  <a:srgbClr val="B9C4D6"/>
+                </a:solidFill>
+                <a:latin typeface="Arial"/>
+              </a:rPr>
+              <a:t>An agent that looks at the phone screen and decides where to tap, evaluated with the official AndroidWorld verifier.</a:t>
+            </a:r>
+          </a:p>
+        </p:txBody>
+      </p:sp>
+      <p:sp>
+        <p:nvSpPr>
+          <p:cNvPr id="9" name="Rectangle 8"/>
+          <p:cNvSpPr/>
+          <p:nvPr/>
+        </p:nvSpPr>
+        <p:spPr>
+          <a:xfrm>
+            <a:off x="685800" y="3794760"/>
+            <a:ext cx="1005840" cy="54864"/>
+          </a:xfrm>
+          <a:prstGeom prst="rect">
+            <a:avLst/>
+          </a:prstGeom>
+          <a:solidFill>
+            <a:srgbClr val="0065BD"/>
+          </a:solidFill>
+          <a:ln>
+            <a:noFill/>
+          </a:ln>
+          <a:effectLst/>
+        </p:spPr>
+        <p:style>
+          <a:lnRef idx="1">
+            <a:schemeClr val="accent1"/>
+          </a:lnRef>
+          <a:fillRef idx="3">
+            <a:schemeClr val="accent1"/>
+          </a:fillRef>
+          <a:effectRef idx="2">
+            <a:schemeClr val="accent1"/>
+          </a:effectRef>
+          <a:fontRef idx="minor">
+            <a:schemeClr val="lt1"/>
+          </a:fontRef>
+        </p:style>
+        <p:txBody>
+          <a:bodyPr rtlCol="0" anchor="ctr"/>
+          <a:lstStyle/>
+          <a:p/>
+        </p:txBody>
+      </p:sp>
+      <p:sp>
+        <p:nvSpPr>
+          <p:cNvPr id="10" name="TextBox 9"/>
+          <p:cNvSpPr txBox="1"/>
+          <p:nvPr/>
+        </p:nvSpPr>
+        <p:spPr>
+          <a:xfrm>
+            <a:off x="685800" y="4251960"/>
+            <a:ext cx="3474720" cy="274320"/>
+          </a:xfrm>
+          <a:prstGeom prst="rect">
+            <a:avLst/>
+          </a:prstGeom>
+          <a:noFill/>
+        </p:spPr>
+        <p:txBody>
+          <a:bodyPr wrap="square" anchor="t" lIns="73152" rIns="73152">
+            <a:spAutoFit/>
+          </a:bodyPr>
+          <a:lstStyle/>
+          <a:p>
+            <a:pPr algn="l">
+              <a:lnSpc>
+                <a:spcPct val="110000"/>
+              </a:lnSpc>
+            </a:pPr>
+            <a:r>
+              <a:rPr sz="1100" b="1" i="0">
+                <a:solidFill>
+                  <a:srgbClr val="64A0C8"/>
+                </a:solidFill>
+                <a:latin typeface="Arial"/>
+              </a:rPr>
+              <a:t>TEAM MEMBERS</a:t>
+            </a:r>
+          </a:p>
+        </p:txBody>
+      </p:sp>
+      <p:sp>
+        <p:nvSpPr>
+          <p:cNvPr id="11" name="TextBox 10"/>
+          <p:cNvSpPr txBox="1"/>
+          <p:nvPr/>
+        </p:nvSpPr>
+        <p:spPr>
+          <a:xfrm>
+            <a:off x="685800" y="4553712"/>
+            <a:ext cx="2286000" cy="1737360"/>
+          </a:xfrm>
+          <a:prstGeom prst="rect">
+            <a:avLst/>
+          </a:prstGeom>
+          <a:noFill/>
+        </p:spPr>
+        <p:txBody>
+          <a:bodyPr wrap="square" anchor="t" lIns="73152" rIns="73152">
+            <a:spAutoFit/>
+          </a:bodyPr>
+          <a:lstStyle/>
+          <a:p>
+            <a:pPr algn="l">
+              <a:lnSpc>
+                <a:spcPct val="128000"/>
+              </a:lnSpc>
+            </a:pPr>
+            <a:r>
+              <a:rPr sz="1300" b="0" i="0">
+                <a:solidFill>
+                  <a:srgbClr val="FFFFFF"/>
+                </a:solidFill>
+                <a:latin typeface="Arial"/>
+              </a:rPr>
+              <a:t>Danh Phuong Le</a:t>
+            </a:r>
+          </a:p>
+          <a:p>
+            <a:pPr algn="l">
+              <a:lnSpc>
+                <a:spcPct val="128000"/>
+              </a:lnSpc>
+            </a:pPr>
+            <a:r>
+              <a:rPr sz="1300" b="0" i="0">
+                <a:solidFill>
+                  <a:srgbClr val="FFFFFF"/>
+                </a:solidFill>
+                <a:latin typeface="Arial"/>
+              </a:rPr>
+              <a:t>Ssu-Cheng Chen</a:t>
+            </a:r>
+          </a:p>
+          <a:p>
+            <a:pPr algn="l">
+              <a:lnSpc>
+                <a:spcPct val="128000"/>
+              </a:lnSpc>
+            </a:pPr>
+            <a:r>
+              <a:rPr sz="1300" b="0" i="0">
+                <a:solidFill>
+                  <a:srgbClr val="FFFFFF"/>
+                </a:solidFill>
+                <a:latin typeface="Arial"/>
+              </a:rPr>
+              <a:t>Hayati Ömer Koç</a:t>
+            </a:r>
+          </a:p>
+          <a:p>
+            <a:pPr algn="l">
+              <a:lnSpc>
+                <a:spcPct val="128000"/>
+              </a:lnSpc>
+            </a:pPr>
+            <a:r>
+              <a:rPr sz="1300" b="0" i="0">
+                <a:solidFill>
+                  <a:srgbClr val="FFFFFF"/>
+                </a:solidFill>
+                <a:latin typeface="Arial"/>
+              </a:rPr>
+              <a:t>Jia Qi</a:t>
+            </a:r>
+          </a:p>
+          <a:p>
+            <a:pPr algn="l">
+              <a:lnSpc>
+                <a:spcPct val="128000"/>
+              </a:lnSpc>
+            </a:pPr>
+            <a:r>
+              <a:rPr sz="1300" b="0" i="0">
+                <a:solidFill>
+                  <a:srgbClr val="FFFFFF"/>
+                </a:solidFill>
+                <a:latin typeface="Arial"/>
+              </a:rPr>
+              <a:t>Tin Nghia Nguyen</a:t>
+            </a:r>
+          </a:p>
+        </p:txBody>
+      </p:sp>
+      <p:sp>
+        <p:nvSpPr>
+          <p:cNvPr id="12" name="TextBox 11"/>
+          <p:cNvSpPr txBox="1"/>
+          <p:nvPr/>
+        </p:nvSpPr>
+        <p:spPr>
+          <a:xfrm>
+            <a:off x="2926080" y="4553712"/>
+            <a:ext cx="1280160" cy="1737360"/>
+          </a:xfrm>
+          <a:prstGeom prst="rect">
+            <a:avLst/>
+          </a:prstGeom>
+          <a:noFill/>
+        </p:spPr>
+        <p:txBody>
+          <a:bodyPr wrap="square" anchor="t" lIns="73152" rIns="73152">
+            <a:spAutoFit/>
+          </a:bodyPr>
+          <a:lstStyle/>
+          <a:p>
+            <a:pPr algn="l">
+              <a:lnSpc>
+                <a:spcPct val="128000"/>
+              </a:lnSpc>
+            </a:pPr>
+            <a:r>
+              <a:rPr sz="1300" b="0" i="0">
+                <a:solidFill>
+                  <a:srgbClr val="B9C4D6"/>
+                </a:solidFill>
+                <a:latin typeface="Arial"/>
+              </a:rPr>
+              <a:t>03824340</a:t>
+            </a:r>
+          </a:p>
+          <a:p>
+            <a:pPr algn="l">
+              <a:lnSpc>
+                <a:spcPct val="128000"/>
+              </a:lnSpc>
+            </a:pPr>
+            <a:r>
+              <a:rPr sz="1300" b="0" i="0">
+                <a:solidFill>
+                  <a:srgbClr val="B9C4D6"/>
+                </a:solidFill>
+                <a:latin typeface="Arial"/>
+              </a:rPr>
+              <a:t>03827578</a:t>
+            </a:r>
+          </a:p>
+          <a:p>
+            <a:pPr algn="l">
+              <a:lnSpc>
+                <a:spcPct val="128000"/>
+              </a:lnSpc>
+            </a:pPr>
+            <a:r>
+              <a:rPr sz="1300" b="0" i="0">
+                <a:solidFill>
+                  <a:srgbClr val="B9C4D6"/>
+                </a:solidFill>
+                <a:latin typeface="Arial"/>
+              </a:rPr>
+              <a:t>03801613</a:t>
+            </a:r>
+          </a:p>
+          <a:p>
+            <a:pPr algn="l">
+              <a:lnSpc>
+                <a:spcPct val="128000"/>
+              </a:lnSpc>
+            </a:pPr>
+            <a:r>
+              <a:rPr sz="1300" b="0" i="0">
+                <a:solidFill>
+                  <a:srgbClr val="B9C4D6"/>
+                </a:solidFill>
+                <a:latin typeface="Arial"/>
+              </a:rPr>
+              <a:t>03812325</a:t>
+            </a:r>
+          </a:p>
+          <a:p>
+            <a:pPr algn="l">
+              <a:lnSpc>
+                <a:spcPct val="128000"/>
+              </a:lnSpc>
+            </a:pPr>
+            <a:r>
+              <a:rPr sz="1300" b="0" i="0">
+                <a:solidFill>
+                  <a:srgbClr val="B9C4D6"/>
+                </a:solidFill>
+                <a:latin typeface="Arial"/>
+              </a:rPr>
+              <a:t>03826855</a:t>
+            </a:r>
+          </a:p>
+        </p:txBody>
+      </p:sp>
+      <p:sp>
+        <p:nvSpPr>
+          <p:cNvPr id="13" name="TextBox 12"/>
+          <p:cNvSpPr txBox="1"/>
+          <p:nvPr/>
+        </p:nvSpPr>
+        <p:spPr>
+          <a:xfrm>
+            <a:off x="4617720" y="4251960"/>
+            <a:ext cx="2377440" cy="274320"/>
+          </a:xfrm>
+          <a:prstGeom prst="rect">
+            <a:avLst/>
+          </a:prstGeom>
+          <a:noFill/>
+        </p:spPr>
+        <p:txBody>
+          <a:bodyPr wrap="square" anchor="t" lIns="73152" rIns="73152">
+            <a:spAutoFit/>
+          </a:bodyPr>
+          <a:lstStyle/>
+          <a:p>
+            <a:pPr algn="l">
+              <a:lnSpc>
+                <a:spcPct val="110000"/>
+              </a:lnSpc>
+            </a:pPr>
+            <a:r>
+              <a:rPr sz="1100" b="1" i="0">
+                <a:solidFill>
+                  <a:srgbClr val="64A0C8"/>
+                </a:solidFill>
+                <a:latin typeface="Arial"/>
+              </a:rPr>
+              <a:t>LECTURERS</a:t>
+            </a:r>
+          </a:p>
+        </p:txBody>
+      </p:sp>
+      <p:sp>
+        <p:nvSpPr>
+          <p:cNvPr id="14" name="TextBox 13"/>
+          <p:cNvSpPr txBox="1"/>
+          <p:nvPr/>
+        </p:nvSpPr>
+        <p:spPr>
+          <a:xfrm>
+            <a:off x="4617720" y="4553712"/>
+            <a:ext cx="2377440" cy="1097280"/>
+          </a:xfrm>
+          <a:prstGeom prst="rect">
+            <a:avLst/>
+          </a:prstGeom>
+          <a:noFill/>
+        </p:spPr>
+        <p:txBody>
+          <a:bodyPr wrap="square" anchor="t" lIns="73152" rIns="73152">
+            <a:spAutoFit/>
+          </a:bodyPr>
+          <a:lstStyle/>
+          <a:p>
+            <a:pPr algn="l">
+              <a:lnSpc>
+                <a:spcPct val="128000"/>
+              </a:lnSpc>
+            </a:pPr>
+            <a:r>
+              <a:rPr sz="1300" b="0" i="0">
+                <a:solidFill>
+                  <a:srgbClr val="FFFFFF"/>
+                </a:solidFill>
+                <a:latin typeface="Arial"/>
+              </a:rPr>
+              <a:t>Haoyuan Jiang</a:t>
+            </a:r>
+          </a:p>
+          <a:p>
+            <a:pPr algn="l">
+              <a:lnSpc>
+                <a:spcPct val="128000"/>
+              </a:lnSpc>
+            </a:pPr>
+            <a:r>
+              <a:rPr sz="1300" b="0" i="0">
+                <a:solidFill>
+                  <a:srgbClr val="FFFFFF"/>
+                </a:solidFill>
+                <a:latin typeface="Arial"/>
+              </a:rPr>
+              <a:t>Xuerui Zhang</a:t>
+            </a:r>
+          </a:p>
+          <a:p>
+            <a:pPr algn="l">
+              <a:lnSpc>
+                <a:spcPct val="128000"/>
+              </a:lnSpc>
+            </a:pPr>
+            <a:r>
+              <a:rPr sz="1300" b="0" i="0">
+                <a:solidFill>
+                  <a:srgbClr val="FFFFFF"/>
+                </a:solidFill>
+                <a:latin typeface="Arial"/>
+              </a:rPr>
+              <a:t>Zhenyu Wang</a:t>
+            </a:r>
+          </a:p>
+        </p:txBody>
+      </p:sp>
+      <p:pic>
+        <p:nvPicPr>
+          <p:cNvPr id="15" name="Picture 14" descr="traj_6.png"/>
+          <p:cNvPicPr>
+            <a:picLocks noChangeAspect="1"/>
+          </p:cNvPicPr>
+          <p:nvPr/>
+        </p:nvPicPr>
+        <p:blipFill>
+          <a:blip r:embed="rId3"/>
+          <a:srcRect t="8000"/>
+          <a:stretch>
+            <a:fillRect/>
+          </a:stretch>
+        </p:blipFill>
+        <p:spPr>
+          <a:xfrm rot="21120000">
+            <a:off x="7589520" y="1325880"/>
+            <a:ext cx="2016252" cy="4122115"/>
+          </a:xfrm>
+          <a:prstGeom prst="roundRect">
+            <a:avLst/>
+          </a:prstGeom>
+          <a:ln w="76200">
+            <a:solidFill>
+              <a:srgbClr val="1B1F2A"/>
+            </a:solidFill>
+          </a:ln>
+        </p:spPr>
+      </p:pic>
+      <p:pic>
+        <p:nvPicPr>
+          <p:cNvPr id="16" name="Picture 15" descr="traj_3.png"/>
+          <p:cNvPicPr>
+            <a:picLocks noChangeAspect="1"/>
+          </p:cNvPicPr>
+          <p:nvPr/>
+        </p:nvPicPr>
+        <p:blipFill>
+          <a:blip r:embed="rId4"/>
+          <a:srcRect t="8000"/>
+          <a:stretch>
+            <a:fillRect/>
+          </a:stretch>
+        </p:blipFill>
+        <p:spPr>
+          <a:xfrm rot="480000">
+            <a:off x="9829800" y="1325880"/>
+            <a:ext cx="2016252" cy="4122115"/>
+          </a:xfrm>
+          <a:prstGeom prst="roundRect">
+            <a:avLst/>
+          </a:prstGeom>
+          <a:ln w="76200">
+            <a:solidFill>
+              <a:srgbClr val="1B1F2A"/>
+            </a:solidFill>
+          </a:ln>
+        </p:spPr>
+      </p:pic>
+      <p:pic>
+        <p:nvPicPr>
+          <p:cNvPr id="17" name="Picture 16" descr="osmand_pass_4.png"/>
+          <p:cNvPicPr>
+            <a:picLocks noChangeAspect="1"/>
+          </p:cNvPicPr>
+          <p:nvPr/>
+        </p:nvPicPr>
+        <p:blipFill>
+          <a:blip r:embed="rId5"/>
+          <a:srcRect t="8000"/>
+          <a:stretch>
+            <a:fillRect/>
+          </a:stretch>
+        </p:blipFill>
+        <p:spPr>
+          <a:xfrm>
+            <a:off x="8549640" y="777240"/>
+            <a:ext cx="2366010" cy="4837176"/>
+          </a:xfrm>
+          <a:prstGeom prst="roundRect">
+            <a:avLst/>
+          </a:prstGeom>
+          <a:ln w="76200">
+            <a:solidFill>
+              <a:srgbClr val="1B1F2A"/>
+            </a:solidFill>
+          </a:ln>
+        </p:spPr>
+      </p:pic>
+      <p:sp>
+        <p:nvSpPr>
+          <p:cNvPr id="18" name="TextBox 17"/>
+          <p:cNvSpPr txBox="1"/>
+          <p:nvPr/>
+        </p:nvSpPr>
+        <p:spPr>
+          <a:xfrm>
+            <a:off x="7223760" y="6172200"/>
+            <a:ext cx="4965192" cy="320040"/>
           </a:xfrm>
           <a:prstGeom prst="rect">
             <a:avLst/>
@@ -7068,485 +7811,13 @@
               </a:lnSpc>
             </a:pPr>
             <a:r>
-              <a:rPr sz="3000" b="1" i="0">
-                <a:solidFill>
-                  <a:srgbClr val="2F3440"/>
-                </a:solidFill>
-                <a:latin typeface="Arial"/>
-              </a:rPr>
-              <a:t>AGENTIC AI IN MODERN BUSINESS</a:t>
-            </a:r>
-          </a:p>
-        </p:txBody>
-      </p:sp>
-      <p:sp>
-        <p:nvSpPr>
-          <p:cNvPr id="4" name="TextBox 3"/>
-          <p:cNvSpPr txBox="1"/>
-          <p:nvPr/>
-        </p:nvSpPr>
-        <p:spPr>
-          <a:xfrm>
-            <a:off x="822960" y="1508760"/>
-            <a:ext cx="10515600" cy="1005840"/>
-          </a:xfrm>
-          <a:prstGeom prst="rect">
-            <a:avLst/>
-          </a:prstGeom>
-          <a:noFill/>
-        </p:spPr>
-        <p:txBody>
-          <a:bodyPr wrap="square" anchor="t" lIns="73152" rIns="73152">
-            <a:spAutoFit/>
-          </a:bodyPr>
-          <a:lstStyle/>
-          <a:p>
-            <a:pPr algn="ctr">
-              <a:lnSpc>
-                <a:spcPct val="110000"/>
-              </a:lnSpc>
-            </a:pPr>
-            <a:r>
-              <a:rPr sz="6000" b="1" i="0">
-                <a:solidFill>
-                  <a:srgbClr val="2A4FB5"/>
-                </a:solidFill>
-                <a:latin typeface="Arial"/>
-              </a:rPr>
-              <a:t>PRESENTATION</a:t>
-            </a:r>
-          </a:p>
-        </p:txBody>
-      </p:sp>
-      <p:sp>
-        <p:nvSpPr>
-          <p:cNvPr id="5" name="TextBox 4"/>
-          <p:cNvSpPr txBox="1"/>
-          <p:nvPr/>
-        </p:nvSpPr>
-        <p:spPr>
-          <a:xfrm>
-            <a:off x="822960" y="2514600"/>
-            <a:ext cx="10515600" cy="365760"/>
-          </a:xfrm>
-          <a:prstGeom prst="rect">
-            <a:avLst/>
-          </a:prstGeom>
-          <a:noFill/>
-        </p:spPr>
-        <p:txBody>
-          <a:bodyPr wrap="square" anchor="t" lIns="73152" rIns="73152">
-            <a:spAutoFit/>
-          </a:bodyPr>
-          <a:lstStyle/>
-          <a:p>
-            <a:pPr algn="ctr">
-              <a:lnSpc>
-                <a:spcPct val="110000"/>
-              </a:lnSpc>
-            </a:pPr>
-            <a:r>
-              <a:rPr sz="1600" b="0" i="0">
+              <a:rPr sz="1100" b="0" i="0">
                 <a:solidFill>
                   <a:srgbClr val="5E6773"/>
                 </a:solidFill>
                 <a:latin typeface="Arial"/>
               </a:rPr>
-              <a:t>TUM School of Management</a:t>
-            </a:r>
-          </a:p>
-        </p:txBody>
-      </p:sp>
-      <p:sp>
-        <p:nvSpPr>
-          <p:cNvPr id="6" name="TextBox 5"/>
-          <p:cNvSpPr txBox="1"/>
-          <p:nvPr/>
-        </p:nvSpPr>
-        <p:spPr>
-          <a:xfrm>
-            <a:off x="822960" y="2971800"/>
-            <a:ext cx="10515600" cy="457200"/>
-          </a:xfrm>
-          <a:prstGeom prst="rect">
-            <a:avLst/>
-          </a:prstGeom>
-          <a:noFill/>
-        </p:spPr>
-        <p:txBody>
-          <a:bodyPr wrap="square" anchor="t" lIns="73152" rIns="73152">
-            <a:spAutoFit/>
-          </a:bodyPr>
-          <a:lstStyle/>
-          <a:p>
-            <a:pPr algn="ctr">
-              <a:lnSpc>
-                <a:spcPct val="110000"/>
-              </a:lnSpc>
-            </a:pPr>
-            <a:r>
-              <a:rPr sz="2000" b="1" i="0">
-                <a:solidFill>
-                  <a:srgbClr val="072140"/>
-                </a:solidFill>
-                <a:latin typeface="Arial"/>
-              </a:rPr>
-              <a:t>One GUI agent for seven AndroidWorld tasks</a:t>
-            </a:r>
-          </a:p>
-        </p:txBody>
-      </p:sp>
-      <p:sp>
-        <p:nvSpPr>
-          <p:cNvPr id="7" name="TextBox 6"/>
-          <p:cNvSpPr txBox="1"/>
-          <p:nvPr/>
-        </p:nvSpPr>
-        <p:spPr>
-          <a:xfrm>
-            <a:off x="1097280" y="3840480"/>
-            <a:ext cx="4114800" cy="365760"/>
-          </a:xfrm>
-          <a:prstGeom prst="rect">
-            <a:avLst/>
-          </a:prstGeom>
-          <a:noFill/>
-        </p:spPr>
-        <p:txBody>
-          <a:bodyPr wrap="square" anchor="t" lIns="73152" rIns="73152">
-            <a:spAutoFit/>
-          </a:bodyPr>
-          <a:lstStyle/>
-          <a:p>
-            <a:pPr algn="l">
-              <a:lnSpc>
-                <a:spcPct val="110000"/>
-              </a:lnSpc>
-            </a:pPr>
-            <a:r>
-              <a:rPr sz="1500" b="1" i="0">
-                <a:solidFill>
-                  <a:srgbClr val="072140"/>
-                </a:solidFill>
-                <a:latin typeface="Arial"/>
-              </a:rPr>
-              <a:t>Team members</a:t>
-            </a:r>
-          </a:p>
-        </p:txBody>
-      </p:sp>
-      <p:sp>
-        <p:nvSpPr>
-          <p:cNvPr id="8" name="TextBox 7"/>
-          <p:cNvSpPr txBox="1"/>
-          <p:nvPr/>
-        </p:nvSpPr>
-        <p:spPr>
-          <a:xfrm>
-            <a:off x="1097280" y="4206240"/>
-            <a:ext cx="2651760" cy="1828800"/>
-          </a:xfrm>
-          <a:prstGeom prst="rect">
-            <a:avLst/>
-          </a:prstGeom>
-          <a:noFill/>
-        </p:spPr>
-        <p:txBody>
-          <a:bodyPr wrap="square" anchor="t" lIns="73152" rIns="73152">
-            <a:spAutoFit/>
-          </a:bodyPr>
-          <a:lstStyle/>
-          <a:p>
-            <a:pPr algn="l">
-              <a:lnSpc>
-                <a:spcPct val="125000"/>
-              </a:lnSpc>
-            </a:pPr>
-            <a:r>
-              <a:rPr sz="1400" b="0" i="0">
-                <a:solidFill>
-                  <a:srgbClr val="222A35"/>
-                </a:solidFill>
-                <a:latin typeface="Arial"/>
-              </a:rPr>
-              <a:t>Danh Phuong Le</a:t>
-            </a:r>
-          </a:p>
-          <a:p>
-            <a:pPr algn="l">
-              <a:lnSpc>
-                <a:spcPct val="125000"/>
-              </a:lnSpc>
-            </a:pPr>
-            <a:r>
-              <a:rPr sz="1400" b="0" i="0">
-                <a:solidFill>
-                  <a:srgbClr val="222A35"/>
-                </a:solidFill>
-                <a:latin typeface="Arial"/>
-              </a:rPr>
-              <a:t>Ssu-Cheng Chen</a:t>
-            </a:r>
-          </a:p>
-          <a:p>
-            <a:pPr algn="l">
-              <a:lnSpc>
-                <a:spcPct val="125000"/>
-              </a:lnSpc>
-            </a:pPr>
-            <a:r>
-              <a:rPr sz="1400" b="0" i="0">
-                <a:solidFill>
-                  <a:srgbClr val="222A35"/>
-                </a:solidFill>
-                <a:latin typeface="Arial"/>
-              </a:rPr>
-              <a:t>Hayati Ömer Koç</a:t>
-            </a:r>
-          </a:p>
-          <a:p>
-            <a:pPr algn="l">
-              <a:lnSpc>
-                <a:spcPct val="125000"/>
-              </a:lnSpc>
-            </a:pPr>
-            <a:r>
-              <a:rPr sz="1400" b="0" i="0">
-                <a:solidFill>
-                  <a:srgbClr val="222A35"/>
-                </a:solidFill>
-                <a:latin typeface="Arial"/>
-              </a:rPr>
-              <a:t>Jia Qi</a:t>
-            </a:r>
-          </a:p>
-          <a:p>
-            <a:pPr algn="l">
-              <a:lnSpc>
-                <a:spcPct val="125000"/>
-              </a:lnSpc>
-            </a:pPr>
-            <a:r>
-              <a:rPr sz="1400" b="0" i="0">
-                <a:solidFill>
-                  <a:srgbClr val="222A35"/>
-                </a:solidFill>
-                <a:latin typeface="Arial"/>
-              </a:rPr>
-              <a:t>Tin Nghia Nguyen</a:t>
-            </a:r>
-          </a:p>
-        </p:txBody>
-      </p:sp>
-      <p:sp>
-        <p:nvSpPr>
-          <p:cNvPr id="9" name="TextBox 8"/>
-          <p:cNvSpPr txBox="1"/>
-          <p:nvPr/>
-        </p:nvSpPr>
-        <p:spPr>
-          <a:xfrm>
-            <a:off x="3749039" y="4206240"/>
-            <a:ext cx="1463040" cy="1828800"/>
-          </a:xfrm>
-          <a:prstGeom prst="rect">
-            <a:avLst/>
-          </a:prstGeom>
-          <a:noFill/>
-        </p:spPr>
-        <p:txBody>
-          <a:bodyPr wrap="square" anchor="t" lIns="73152" rIns="73152">
-            <a:spAutoFit/>
-          </a:bodyPr>
-          <a:lstStyle/>
-          <a:p>
-            <a:pPr algn="l">
-              <a:lnSpc>
-                <a:spcPct val="125000"/>
-              </a:lnSpc>
-            </a:pPr>
-            <a:r>
-              <a:rPr sz="1400" b="0" i="0">
-                <a:solidFill>
-                  <a:srgbClr val="222A35"/>
-                </a:solidFill>
-                <a:latin typeface="Arial"/>
-              </a:rPr>
-              <a:t>03824340</a:t>
-            </a:r>
-          </a:p>
-          <a:p>
-            <a:pPr algn="l">
-              <a:lnSpc>
-                <a:spcPct val="125000"/>
-              </a:lnSpc>
-            </a:pPr>
-            <a:r>
-              <a:rPr sz="1400" b="0" i="0">
-                <a:solidFill>
-                  <a:srgbClr val="222A35"/>
-                </a:solidFill>
-                <a:latin typeface="Arial"/>
-              </a:rPr>
-              <a:t>03827578</a:t>
-            </a:r>
-          </a:p>
-          <a:p>
-            <a:pPr algn="l">
-              <a:lnSpc>
-                <a:spcPct val="125000"/>
-              </a:lnSpc>
-            </a:pPr>
-            <a:r>
-              <a:rPr sz="1400" b="0" i="0">
-                <a:solidFill>
-                  <a:srgbClr val="222A35"/>
-                </a:solidFill>
-                <a:latin typeface="Arial"/>
-              </a:rPr>
-              <a:t>03801613</a:t>
-            </a:r>
-          </a:p>
-          <a:p>
-            <a:pPr algn="l">
-              <a:lnSpc>
-                <a:spcPct val="125000"/>
-              </a:lnSpc>
-            </a:pPr>
-            <a:r>
-              <a:rPr sz="1400" b="0" i="0">
-                <a:solidFill>
-                  <a:srgbClr val="222A35"/>
-                </a:solidFill>
-                <a:latin typeface="Arial"/>
-              </a:rPr>
-              <a:t>03812325</a:t>
-            </a:r>
-          </a:p>
-          <a:p>
-            <a:pPr algn="l">
-              <a:lnSpc>
-                <a:spcPct val="125000"/>
-              </a:lnSpc>
-            </a:pPr>
-            <a:r>
-              <a:rPr sz="1400" b="0" i="0">
-                <a:solidFill>
-                  <a:srgbClr val="222A35"/>
-                </a:solidFill>
-                <a:latin typeface="Arial"/>
-              </a:rPr>
-              <a:t>03826855</a:t>
-            </a:r>
-          </a:p>
-        </p:txBody>
-      </p:sp>
-      <p:sp>
-        <p:nvSpPr>
-          <p:cNvPr id="10" name="TextBox 9"/>
-          <p:cNvSpPr txBox="1"/>
-          <p:nvPr/>
-        </p:nvSpPr>
-        <p:spPr>
-          <a:xfrm>
-            <a:off x="7680960" y="3840480"/>
-            <a:ext cx="3657600" cy="365760"/>
-          </a:xfrm>
-          <a:prstGeom prst="rect">
-            <a:avLst/>
-          </a:prstGeom>
-          <a:noFill/>
-        </p:spPr>
-        <p:txBody>
-          <a:bodyPr wrap="square" anchor="t" lIns="73152" rIns="73152">
-            <a:spAutoFit/>
-          </a:bodyPr>
-          <a:lstStyle/>
-          <a:p>
-            <a:pPr algn="l">
-              <a:lnSpc>
-                <a:spcPct val="110000"/>
-              </a:lnSpc>
-            </a:pPr>
-            <a:r>
-              <a:rPr sz="1500" b="1" i="0">
-                <a:solidFill>
-                  <a:srgbClr val="072140"/>
-                </a:solidFill>
-                <a:latin typeface="Arial"/>
-              </a:rPr>
-              <a:t>Lecturers</a:t>
-            </a:r>
-          </a:p>
-        </p:txBody>
-      </p:sp>
-      <p:sp>
-        <p:nvSpPr>
-          <p:cNvPr id="11" name="TextBox 10"/>
-          <p:cNvSpPr txBox="1"/>
-          <p:nvPr/>
-        </p:nvSpPr>
-        <p:spPr>
-          <a:xfrm>
-            <a:off x="7680960" y="4206240"/>
-            <a:ext cx="3657600" cy="1371600"/>
-          </a:xfrm>
-          <a:prstGeom prst="rect">
-            <a:avLst/>
-          </a:prstGeom>
-          <a:noFill/>
-        </p:spPr>
-        <p:txBody>
-          <a:bodyPr wrap="square" anchor="t" lIns="73152" rIns="73152">
-            <a:spAutoFit/>
-          </a:bodyPr>
-          <a:lstStyle/>
-          <a:p>
-            <a:pPr algn="l">
-              <a:lnSpc>
-                <a:spcPct val="125000"/>
-              </a:lnSpc>
-            </a:pPr>
-            <a:r>
-              <a:rPr sz="1400" b="0" i="0">
-                <a:solidFill>
-                  <a:srgbClr val="222A35"/>
-                </a:solidFill>
-                <a:latin typeface="Arial"/>
-              </a:rPr>
-              <a:t>Haoyuan Jiang</a:t>
-            </a:r>
-          </a:p>
-          <a:p>
-            <a:pPr algn="l">
-              <a:lnSpc>
-                <a:spcPct val="125000"/>
-              </a:lnSpc>
-            </a:pPr>
-            <a:r>
-              <a:rPr sz="1400" b="0" i="0">
-                <a:solidFill>
-                  <a:srgbClr val="222A35"/>
-                </a:solidFill>
-                <a:latin typeface="Arial"/>
-              </a:rPr>
-              <a:t>Xuerui Zhang</a:t>
-            </a:r>
-          </a:p>
-          <a:p>
-            <a:pPr algn="l">
-              <a:lnSpc>
-                <a:spcPct val="125000"/>
-              </a:lnSpc>
-            </a:pPr>
-            <a:r>
-              <a:rPr sz="1400" b="0" i="0">
-                <a:solidFill>
-                  <a:srgbClr val="222A35"/>
-                </a:solidFill>
-                <a:latin typeface="Arial"/>
-              </a:rPr>
-              <a:t>Zhenyu Wang</a:t>
+              <a:t>Real screens from our evaluation runs</a:t>
             </a:r>
           </a:p>
         </p:txBody>

</xml_diff>